<commit_message>
Add the Table 1b artifacts, CPU eval logs, and the Tema 2 deck.
Co-authored-by: Cursor <cursoragent@cursor.com>
</commit_message>
<xml_diff>
--- a/Tema 2/paper/Tema2.pptx
+++ b/Tema 2/paper/Tema2.pptx
@@ -5,10 +5,10 @@
     <p:sldMasterId id="2147483660" r:id="rId1"/>
   </p:sldMasterIdLst>
   <p:notesMasterIdLst>
-    <p:notesMasterId r:id="rId13"/>
+    <p:notesMasterId r:id="rId15"/>
   </p:notesMasterIdLst>
   <p:handoutMasterIdLst>
-    <p:handoutMasterId r:id="rId14"/>
+    <p:handoutMasterId r:id="rId16"/>
   </p:handoutMasterIdLst>
   <p:sldIdLst>
     <p:sldId id="256" r:id="rId2"/>
@@ -22,6 +22,8 @@
     <p:sldId id="337" r:id="rId10"/>
     <p:sldId id="338" r:id="rId11"/>
     <p:sldId id="339" r:id="rId12"/>
+    <p:sldId id="340" r:id="rId13"/>
+    <p:sldId id="341" r:id="rId14"/>
   </p:sldIdLst>
   <p:sldSz cx="12192000" cy="6858000"/>
   <p:notesSz cx="6858000" cy="9144000"/>
@@ -11798,7 +11800,7 @@
                   </a:r>
                   <a:r>
                     <a:rPr lang="en-US" sz="1600" dirty="0"/>
-                    <a:t>, intrinsic material toughness)</a:t>
+                    <a:t>, intrinsic material toughness</a:t>
                   </a:r>
                 </a:p>
               </p:txBody>
@@ -12233,10 +12235,1939 @@
           </a:prstGeom>
         </p:spPr>
       </p:pic>
+      <p:sp>
+        <p:nvSpPr>
+          <p:cNvPr id="27" name="TextBox 26">
+            <a:extLst>
+              <a:ext uri="{FF2B5EF4-FFF2-40B4-BE49-F238E27FC236}">
+                <a16:creationId xmlns:a16="http://schemas.microsoft.com/office/drawing/2014/main" id="{E75EE087-00E7-9DDC-BD76-23E501D64CE6}"/>
+              </a:ext>
+            </a:extLst>
+          </p:cNvPr>
+          <p:cNvSpPr txBox="1"/>
+          <p:nvPr/>
+        </p:nvSpPr>
+        <p:spPr>
+          <a:xfrm>
+            <a:off x="9407015" y="1627080"/>
+            <a:ext cx="2169042" cy="923330"/>
+          </a:xfrm>
+          <a:prstGeom prst="rect">
+            <a:avLst/>
+          </a:prstGeom>
+          <a:noFill/>
+        </p:spPr>
+        <p:txBody>
+          <a:bodyPr wrap="square" rtlCol="0">
+            <a:spAutoFit/>
+          </a:bodyPr>
+          <a:lstStyle/>
+          <a:p>
+            <a:r>
+              <a:rPr lang="en-US" dirty="0" err="1"/>
+              <a:t>Mentrionat</a:t>
+            </a:r>
+            <a:r>
+              <a:rPr lang="en-US" dirty="0"/>
+              <a:t> eta 0.993 </a:t>
+            </a:r>
+            <a:r>
+              <a:rPr lang="en-US" dirty="0" err="1"/>
+              <a:t>pentru</a:t>
+            </a:r>
+            <a:r>
+              <a:rPr lang="en-US" dirty="0"/>
+              <a:t> Silk </a:t>
+            </a:r>
+            <a:r>
+              <a:rPr lang="en-US" dirty="0" err="1"/>
+              <a:t>si</a:t>
+            </a:r>
+            <a:r>
+              <a:rPr lang="en-US" dirty="0"/>
+              <a:t> 0… </a:t>
+            </a:r>
+            <a:r>
+              <a:rPr lang="en-US" dirty="0" err="1"/>
+              <a:t>pentru</a:t>
+            </a:r>
+            <a:r>
+              <a:rPr lang="en-US" dirty="0"/>
+              <a:t> D.</a:t>
+            </a:r>
+          </a:p>
+        </p:txBody>
+      </p:sp>
     </p:spTree>
     <p:extLst>
       <p:ext uri="{BB962C8B-B14F-4D97-AF65-F5344CB8AC3E}">
         <p14:creationId xmlns:p14="http://schemas.microsoft.com/office/powerpoint/2010/main" val="1788620930"/>
+      </p:ext>
+    </p:extLst>
+  </p:cSld>
+  <p:clrMapOvr>
+    <a:masterClrMapping/>
+  </p:clrMapOvr>
+</p:sld>
+</file>
+
+<file path=ppt/slides/slide12.xml><?xml version="1.0" encoding="utf-8"?>
+<p:sld xmlns:a="http://schemas.openxmlformats.org/drawingml/2006/main" xmlns:r="http://schemas.openxmlformats.org/officeDocument/2006/relationships" xmlns:p="http://schemas.openxmlformats.org/presentationml/2006/main">
+  <p:cSld>
+    <p:spTree>
+      <p:nvGrpSpPr>
+        <p:cNvPr id="1" name="">
+          <a:extLst>
+            <a:ext uri="{FF2B5EF4-FFF2-40B4-BE49-F238E27FC236}">
+              <a16:creationId xmlns:a16="http://schemas.microsoft.com/office/drawing/2014/main" id="{FD53C0A6-1CCB-CE18-ACF9-3F611F1E8D7B}"/>
+            </a:ext>
+          </a:extLst>
+        </p:cNvPr>
+        <p:cNvGrpSpPr/>
+        <p:nvPr/>
+      </p:nvGrpSpPr>
+      <p:grpSpPr>
+        <a:xfrm>
+          <a:off x="0" y="0"/>
+          <a:ext cx="0" cy="0"/>
+          <a:chOff x="0" y="0"/>
+          <a:chExt cx="0" cy="0"/>
+        </a:xfrm>
+      </p:grpSpPr>
+      <p:sp>
+        <p:nvSpPr>
+          <p:cNvPr id="4" name="Title 3">
+            <a:extLst>
+              <a:ext uri="{FF2B5EF4-FFF2-40B4-BE49-F238E27FC236}">
+                <a16:creationId xmlns:a16="http://schemas.microsoft.com/office/drawing/2014/main" id="{5CD12C75-291A-055A-1B61-6BFE62A17C72}"/>
+              </a:ext>
+            </a:extLst>
+          </p:cNvPr>
+          <p:cNvSpPr>
+            <a:spLocks noGrp="1"/>
+          </p:cNvSpPr>
+          <p:nvPr>
+            <p:ph type="title"/>
+          </p:nvPr>
+        </p:nvSpPr>
+        <p:spPr/>
+        <p:txBody>
+          <a:bodyPr>
+            <a:normAutofit fontScale="90000"/>
+          </a:bodyPr>
+          <a:lstStyle/>
+          <a:p>
+            <a:r>
+              <a:rPr lang="en-US" dirty="0">
+                <a:solidFill>
+                  <a:schemeClr val="bg1"/>
+                </a:solidFill>
+              </a:rPr>
+              <a:t>Off-Centre Impact</a:t>
+            </a:r>
+            <a:endParaRPr lang="ro-RO" dirty="0">
+              <a:solidFill>
+                <a:schemeClr val="bg1"/>
+              </a:solidFill>
+            </a:endParaRPr>
+          </a:p>
+        </p:txBody>
+      </p:sp>
+      <p:pic>
+        <p:nvPicPr>
+          <p:cNvPr id="5" name="Picture 4">
+            <a:extLst>
+              <a:ext uri="{FF2B5EF4-FFF2-40B4-BE49-F238E27FC236}">
+                <a16:creationId xmlns:a16="http://schemas.microsoft.com/office/drawing/2014/main" id="{DC852C5E-CBC0-EC2D-F702-FE17998311C7}"/>
+              </a:ext>
+            </a:extLst>
+          </p:cNvPr>
+          <p:cNvPicPr>
+            <a:picLocks noChangeAspect="1"/>
+          </p:cNvPicPr>
+          <p:nvPr/>
+        </p:nvPicPr>
+        <p:blipFill>
+          <a:blip r:embed="rId2">
+            <a:clrChange>
+              <a:clrFrom>
+                <a:srgbClr val="000000"/>
+              </a:clrFrom>
+              <a:clrTo>
+                <a:srgbClr val="000000">
+                  <a:alpha val="0"/>
+                </a:srgbClr>
+              </a:clrTo>
+            </a:clrChange>
+            <a:extLst>
+              <a:ext uri="{28A0092B-C50C-407E-A947-70E740481C1C}">
+                <a14:useLocalDpi xmlns:a14="http://schemas.microsoft.com/office/drawing/2010/main" val="0"/>
+              </a:ext>
+            </a:extLst>
+          </a:blip>
+          <a:stretch>
+            <a:fillRect/>
+          </a:stretch>
+        </p:blipFill>
+        <p:spPr>
+          <a:xfrm>
+            <a:off x="10432471" y="6323329"/>
+            <a:ext cx="1492133" cy="496892"/>
+          </a:xfrm>
+          <a:prstGeom prst="rect">
+            <a:avLst/>
+          </a:prstGeom>
+        </p:spPr>
+      </p:pic>
+      <p:pic>
+        <p:nvPicPr>
+          <p:cNvPr id="2" name="Picture 1">
+            <a:extLst>
+              <a:ext uri="{FF2B5EF4-FFF2-40B4-BE49-F238E27FC236}">
+                <a16:creationId xmlns:a16="http://schemas.microsoft.com/office/drawing/2014/main" id="{338FD5FF-2935-9EE6-3C51-2A2E2ACB9660}"/>
+              </a:ext>
+            </a:extLst>
+          </p:cNvPr>
+          <p:cNvPicPr>
+            <a:picLocks noChangeAspect="1"/>
+          </p:cNvPicPr>
+          <p:nvPr/>
+        </p:nvPicPr>
+        <p:blipFill>
+          <a:blip r:embed="rId3"/>
+          <a:stretch>
+            <a:fillRect/>
+          </a:stretch>
+        </p:blipFill>
+        <p:spPr>
+          <a:xfrm>
+            <a:off x="2103474" y="1327318"/>
+            <a:ext cx="7772400" cy="2417094"/>
+          </a:xfrm>
+          <a:prstGeom prst="rect">
+            <a:avLst/>
+          </a:prstGeom>
+        </p:spPr>
+      </p:pic>
+      <mc:AlternateContent xmlns:mc="http://schemas.openxmlformats.org/markup-compatibility/2006">
+        <mc:Choice xmlns:a14="http://schemas.microsoft.com/office/drawing/2010/main" Requires="a14">
+          <p:sp>
+            <p:nvSpPr>
+              <p:cNvPr id="6" name="TextBox 5">
+                <a:extLst>
+                  <a:ext uri="{FF2B5EF4-FFF2-40B4-BE49-F238E27FC236}">
+                    <a16:creationId xmlns:a16="http://schemas.microsoft.com/office/drawing/2014/main" id="{CD64989F-B8B1-C094-6E22-C8A56880BD7C}"/>
+                  </a:ext>
+                </a:extLst>
+              </p:cNvPr>
+              <p:cNvSpPr txBox="1"/>
+              <p:nvPr/>
+            </p:nvSpPr>
+            <p:spPr>
+              <a:xfrm>
+                <a:off x="1024550" y="4202658"/>
+                <a:ext cx="3671839" cy="818366"/>
+              </a:xfrm>
+              <a:prstGeom prst="rect">
+                <a:avLst/>
+              </a:prstGeom>
+              <a:noFill/>
+            </p:spPr>
+            <p:txBody>
+              <a:bodyPr wrap="none" lIns="0" tIns="0" rIns="0" bIns="0" rtlCol="0">
+                <a:spAutoFit/>
+              </a:bodyPr>
+              <a:lstStyle/>
+              <a:p>
+                <a14:m>
+                  <m:oMathPara xmlns:m="http://schemas.openxmlformats.org/officeDocument/2006/math">
+                    <m:oMathParaPr>
+                      <m:jc m:val="centerGroup"/>
+                    </m:oMathParaPr>
+                    <m:oMath xmlns:m="http://schemas.openxmlformats.org/officeDocument/2006/math">
+                      <m:sSub>
+                        <m:sSubPr>
+                          <m:ctrlPr>
+                            <a:rPr lang="en-US" i="1" smtClean="0">
+                              <a:latin typeface="Cambria Math" panose="02040503050406030204" pitchFamily="18" charset="0"/>
+                            </a:rPr>
+                          </m:ctrlPr>
+                        </m:sSubPr>
+                        <m:e>
+                          <m:r>
+                            <a:rPr lang="en-US" i="1" smtClean="0">
+                              <a:latin typeface="Cambria Math" panose="02040503050406030204" pitchFamily="18" charset="0"/>
+                            </a:rPr>
+                            <m:t>𝜖</m:t>
+                          </m:r>
+                        </m:e>
+                        <m:sub>
+                          <m:r>
+                            <a:rPr lang="en-US" i="1" smtClean="0">
+                              <a:latin typeface="Cambria Math" panose="02040503050406030204" pitchFamily="18" charset="0"/>
+                            </a:rPr>
+                            <m:t>𝑜</m:t>
+                          </m:r>
+                        </m:sub>
+                      </m:sSub>
+                      <m:d>
+                        <m:dPr>
+                          <m:ctrlPr>
+                            <a:rPr lang="en-US" i="1" smtClean="0">
+                              <a:latin typeface="Cambria Math" panose="02040503050406030204" pitchFamily="18" charset="0"/>
+                            </a:rPr>
+                          </m:ctrlPr>
+                        </m:dPr>
+                        <m:e>
+                          <m:r>
+                            <a:rPr lang="en-US" i="1" smtClean="0">
+                              <a:latin typeface="Cambria Math" panose="02040503050406030204" pitchFamily="18" charset="0"/>
+                            </a:rPr>
+                            <m:t>𝑤</m:t>
+                          </m:r>
+                        </m:e>
+                      </m:d>
+                      <m:r>
+                        <a:rPr lang="en-US" i="1" smtClean="0">
+                          <a:latin typeface="Cambria Math" panose="02040503050406030204" pitchFamily="18" charset="0"/>
+                        </a:rPr>
+                        <m:t>=</m:t>
+                      </m:r>
+                      <m:d>
+                        <m:dPr>
+                          <m:ctrlPr>
+                            <a:rPr lang="en-US" i="1" smtClean="0">
+                              <a:latin typeface="Cambria Math" panose="02040503050406030204" pitchFamily="18" charset="0"/>
+                            </a:rPr>
+                          </m:ctrlPr>
+                        </m:dPr>
+                        <m:e>
+                          <m:r>
+                            <a:rPr lang="en-US" i="1" smtClean="0">
+                              <a:latin typeface="Cambria Math" panose="02040503050406030204" pitchFamily="18" charset="0"/>
+                            </a:rPr>
+                            <m:t>1+</m:t>
+                          </m:r>
+                          <m:sSub>
+                            <m:sSubPr>
+                              <m:ctrlPr>
+                                <a:rPr lang="en-US" i="1" smtClean="0">
+                                  <a:latin typeface="Cambria Math" panose="02040503050406030204" pitchFamily="18" charset="0"/>
+                                </a:rPr>
+                              </m:ctrlPr>
+                            </m:sSubPr>
+                            <m:e>
+                              <m:r>
+                                <a:rPr lang="en-US" i="1" smtClean="0">
+                                  <a:latin typeface="Cambria Math" panose="02040503050406030204" pitchFamily="18" charset="0"/>
+                                </a:rPr>
+                                <m:t>𝜖</m:t>
+                              </m:r>
+                            </m:e>
+                            <m:sub>
+                              <m:r>
+                                <a:rPr lang="en-US" i="1" smtClean="0">
+                                  <a:latin typeface="Cambria Math" panose="02040503050406030204" pitchFamily="18" charset="0"/>
+                                </a:rPr>
+                                <m:t>𝑝</m:t>
+                              </m:r>
+                            </m:sub>
+                          </m:sSub>
+                        </m:e>
+                      </m:d>
+                      <m:rad>
+                        <m:radPr>
+                          <m:degHide m:val="on"/>
+                          <m:ctrlPr>
+                            <a:rPr lang="en-US" i="1" smtClean="0">
+                              <a:latin typeface="Cambria Math" panose="02040503050406030204" pitchFamily="18" charset="0"/>
+                            </a:rPr>
+                          </m:ctrlPr>
+                        </m:radPr>
+                        <m:deg/>
+                        <m:e>
+                          <m:r>
+                            <a:rPr lang="en-US" i="1" smtClean="0">
+                              <a:latin typeface="Cambria Math" panose="02040503050406030204" pitchFamily="18" charset="0"/>
+                            </a:rPr>
+                            <m:t>1+</m:t>
+                          </m:r>
+                          <m:sSup>
+                            <m:sSupPr>
+                              <m:ctrlPr>
+                                <a:rPr lang="en-US" i="1" smtClean="0">
+                                  <a:latin typeface="Cambria Math" panose="02040503050406030204" pitchFamily="18" charset="0"/>
+                                </a:rPr>
+                              </m:ctrlPr>
+                            </m:sSupPr>
+                            <m:e>
+                              <m:d>
+                                <m:dPr>
+                                  <m:ctrlPr>
+                                    <a:rPr lang="en-US" i="1" smtClean="0">
+                                      <a:latin typeface="Cambria Math" panose="02040503050406030204" pitchFamily="18" charset="0"/>
+                                    </a:rPr>
+                                  </m:ctrlPr>
+                                </m:dPr>
+                                <m:e>
+                                  <m:f>
+                                    <m:fPr>
+                                      <m:ctrlPr>
+                                        <a:rPr lang="en-US" i="1" smtClean="0">
+                                          <a:latin typeface="Cambria Math" panose="02040503050406030204" pitchFamily="18" charset="0"/>
+                                        </a:rPr>
+                                      </m:ctrlPr>
+                                    </m:fPr>
+                                    <m:num>
+                                      <m:r>
+                                        <a:rPr lang="en-US" i="1" smtClean="0">
+                                          <a:latin typeface="Cambria Math" panose="02040503050406030204" pitchFamily="18" charset="0"/>
+                                        </a:rPr>
+                                        <m:t>𝑤</m:t>
+                                      </m:r>
+                                    </m:num>
+                                    <m:den>
+                                      <m:r>
+                                        <a:rPr lang="en-US" i="1" smtClean="0">
+                                          <a:latin typeface="Cambria Math" panose="02040503050406030204" pitchFamily="18" charset="0"/>
+                                        </a:rPr>
+                                        <m:t>𝑅</m:t>
+                                      </m:r>
+                                      <m:r>
+                                        <a:rPr lang="en-US" i="1" smtClean="0">
+                                          <a:latin typeface="Cambria Math" panose="02040503050406030204" pitchFamily="18" charset="0"/>
+                                        </a:rPr>
+                                        <m:t>−</m:t>
+                                      </m:r>
+                                      <m:r>
+                                        <a:rPr lang="en-US" i="1" smtClean="0">
+                                          <a:latin typeface="Cambria Math" panose="02040503050406030204" pitchFamily="18" charset="0"/>
+                                        </a:rPr>
+                                        <m:t>𝑎</m:t>
+                                      </m:r>
+                                    </m:den>
+                                  </m:f>
+                                </m:e>
+                              </m:d>
+                            </m:e>
+                            <m:sup>
+                              <m:r>
+                                <a:rPr lang="en-US" i="1" smtClean="0">
+                                  <a:latin typeface="Cambria Math" panose="02040503050406030204" pitchFamily="18" charset="0"/>
+                                </a:rPr>
+                                <m:t>2</m:t>
+                              </m:r>
+                            </m:sup>
+                          </m:sSup>
+                        </m:e>
+                      </m:rad>
+                      <m:r>
+                        <a:rPr lang="en-US" i="1" smtClean="0">
+                          <a:latin typeface="Cambria Math" panose="02040503050406030204" pitchFamily="18" charset="0"/>
+                        </a:rPr>
+                        <m:t>−1</m:t>
+                      </m:r>
+                    </m:oMath>
+                  </m:oMathPara>
+                </a14:m>
+                <a:endParaRPr lang="en-US" dirty="0"/>
+              </a:p>
+            </p:txBody>
+          </p:sp>
+        </mc:Choice>
+        <mc:Fallback>
+          <p:sp>
+            <p:nvSpPr>
+              <p:cNvPr id="6" name="TextBox 5">
+                <a:extLst>
+                  <a:ext uri="{FF2B5EF4-FFF2-40B4-BE49-F238E27FC236}">
+                    <a16:creationId xmlns:a16="http://schemas.microsoft.com/office/drawing/2014/main" id="{CD64989F-B8B1-C094-6E22-C8A56880BD7C}"/>
+                  </a:ext>
+                </a:extLst>
+              </p:cNvPr>
+              <p:cNvSpPr txBox="1">
+                <a:spLocks noRot="1" noChangeAspect="1" noMove="1" noResize="1" noEditPoints="1" noAdjustHandles="1" noChangeArrowheads="1" noChangeShapeType="1" noTextEdit="1"/>
+              </p:cNvSpPr>
+              <p:nvPr/>
+            </p:nvSpPr>
+            <p:spPr>
+              <a:xfrm>
+                <a:off x="1024550" y="4202658"/>
+                <a:ext cx="3671839" cy="818366"/>
+              </a:xfrm>
+              <a:prstGeom prst="rect">
+                <a:avLst/>
+              </a:prstGeom>
+              <a:blipFill>
+                <a:blip r:embed="rId4"/>
+                <a:stretch>
+                  <a:fillRect l="-345" r="-690"/>
+                </a:stretch>
+              </a:blipFill>
+            </p:spPr>
+            <p:txBody>
+              <a:bodyPr/>
+              <a:lstStyle/>
+              <a:p>
+                <a:r>
+                  <a:rPr lang="en-US">
+                    <a:noFill/>
+                  </a:rPr>
+                  <a:t> </a:t>
+                </a:r>
+              </a:p>
+            </p:txBody>
+          </p:sp>
+        </mc:Fallback>
+      </mc:AlternateContent>
+      <mc:AlternateContent xmlns:mc="http://schemas.openxmlformats.org/markup-compatibility/2006">
+        <mc:Choice xmlns:a14="http://schemas.microsoft.com/office/drawing/2010/main" Requires="a14">
+          <p:sp>
+            <p:nvSpPr>
+              <p:cNvPr id="7" name="TextBox 6">
+                <a:extLst>
+                  <a:ext uri="{FF2B5EF4-FFF2-40B4-BE49-F238E27FC236}">
+                    <a16:creationId xmlns:a16="http://schemas.microsoft.com/office/drawing/2014/main" id="{76FC0351-B8FE-03D7-ECAE-8DACBD7AD296}"/>
+                  </a:ext>
+                </a:extLst>
+              </p:cNvPr>
+              <p:cNvSpPr txBox="1"/>
+              <p:nvPr/>
+            </p:nvSpPr>
+            <p:spPr>
+              <a:xfrm>
+                <a:off x="1370702" y="5362313"/>
+                <a:ext cx="2979534" cy="818366"/>
+              </a:xfrm>
+              <a:prstGeom prst="rect">
+                <a:avLst/>
+              </a:prstGeom>
+              <a:noFill/>
+            </p:spPr>
+            <p:txBody>
+              <a:bodyPr wrap="none" lIns="0" tIns="0" rIns="0" bIns="0" rtlCol="0">
+                <a:spAutoFit/>
+              </a:bodyPr>
+              <a:lstStyle/>
+              <a:p>
+                <a14:m>
+                  <m:oMathPara xmlns:m="http://schemas.openxmlformats.org/officeDocument/2006/math">
+                    <m:oMathParaPr>
+                      <m:jc m:val="centerGroup"/>
+                    </m:oMathParaPr>
+                    <m:oMath xmlns:m="http://schemas.openxmlformats.org/officeDocument/2006/math">
+                      <m:sSub>
+                        <m:sSubPr>
+                          <m:ctrlPr>
+                            <a:rPr lang="en-US" i="1" smtClean="0">
+                              <a:latin typeface="Cambria Math" panose="02040503050406030204" pitchFamily="18" charset="0"/>
+                            </a:rPr>
+                          </m:ctrlPr>
+                        </m:sSubPr>
+                        <m:e>
+                          <m:r>
+                            <a:rPr lang="en-US" i="1" smtClean="0">
+                              <a:latin typeface="Cambria Math" panose="02040503050406030204" pitchFamily="18" charset="0"/>
+                            </a:rPr>
+                            <m:t>𝑤</m:t>
+                          </m:r>
+                        </m:e>
+                        <m:sub>
+                          <m:r>
+                            <a:rPr lang="en-US" i="1" smtClean="0">
+                              <a:latin typeface="Cambria Math" panose="02040503050406030204" pitchFamily="18" charset="0"/>
+                            </a:rPr>
+                            <m:t>𝑏</m:t>
+                          </m:r>
+                        </m:sub>
+                      </m:sSub>
+                      <m:r>
+                        <a:rPr lang="en-US" i="1" smtClean="0">
+                          <a:latin typeface="Cambria Math" panose="02040503050406030204" pitchFamily="18" charset="0"/>
+                        </a:rPr>
+                        <m:t>=</m:t>
+                      </m:r>
+                      <m:d>
+                        <m:dPr>
+                          <m:ctrlPr>
+                            <a:rPr lang="en-US" i="1" smtClean="0">
+                              <a:latin typeface="Cambria Math" panose="02040503050406030204" pitchFamily="18" charset="0"/>
+                            </a:rPr>
+                          </m:ctrlPr>
+                        </m:dPr>
+                        <m:e>
+                          <m:r>
+                            <a:rPr lang="en-US" i="1" smtClean="0">
+                              <a:latin typeface="Cambria Math" panose="02040503050406030204" pitchFamily="18" charset="0"/>
+                            </a:rPr>
+                            <m:t>𝑅</m:t>
+                          </m:r>
+                          <m:r>
+                            <a:rPr lang="en-US" i="1" smtClean="0">
+                              <a:latin typeface="Cambria Math" panose="02040503050406030204" pitchFamily="18" charset="0"/>
+                            </a:rPr>
+                            <m:t>−</m:t>
+                          </m:r>
+                          <m:r>
+                            <a:rPr lang="en-US" i="1" smtClean="0">
+                              <a:latin typeface="Cambria Math" panose="02040503050406030204" pitchFamily="18" charset="0"/>
+                            </a:rPr>
+                            <m:t>𝑎</m:t>
+                          </m:r>
+                        </m:e>
+                      </m:d>
+                      <m:rad>
+                        <m:radPr>
+                          <m:degHide m:val="on"/>
+                          <m:ctrlPr>
+                            <a:rPr lang="en-US" i="1" smtClean="0">
+                              <a:latin typeface="Cambria Math" panose="02040503050406030204" pitchFamily="18" charset="0"/>
+                            </a:rPr>
+                          </m:ctrlPr>
+                        </m:radPr>
+                        <m:deg/>
+                        <m:e>
+                          <m:sSup>
+                            <m:sSupPr>
+                              <m:ctrlPr>
+                                <a:rPr lang="en-US" i="1" smtClean="0">
+                                  <a:latin typeface="Cambria Math" panose="02040503050406030204" pitchFamily="18" charset="0"/>
+                                </a:rPr>
+                              </m:ctrlPr>
+                            </m:sSupPr>
+                            <m:e>
+                              <m:d>
+                                <m:dPr>
+                                  <m:ctrlPr>
+                                    <a:rPr lang="en-US" i="1" smtClean="0">
+                                      <a:latin typeface="Cambria Math" panose="02040503050406030204" pitchFamily="18" charset="0"/>
+                                    </a:rPr>
+                                  </m:ctrlPr>
+                                </m:dPr>
+                                <m:e>
+                                  <m:f>
+                                    <m:fPr>
+                                      <m:ctrlPr>
+                                        <a:rPr lang="en-US" i="1" smtClean="0">
+                                          <a:latin typeface="Cambria Math" panose="02040503050406030204" pitchFamily="18" charset="0"/>
+                                        </a:rPr>
+                                      </m:ctrlPr>
+                                    </m:fPr>
+                                    <m:num>
+                                      <m:r>
+                                        <a:rPr lang="en-US" i="1" smtClean="0">
+                                          <a:latin typeface="Cambria Math" panose="02040503050406030204" pitchFamily="18" charset="0"/>
+                                        </a:rPr>
+                                        <m:t>1+</m:t>
+                                      </m:r>
+                                      <m:sSub>
+                                        <m:sSubPr>
+                                          <m:ctrlPr>
+                                            <a:rPr lang="en-US" i="1" smtClean="0">
+                                              <a:latin typeface="Cambria Math" panose="02040503050406030204" pitchFamily="18" charset="0"/>
+                                            </a:rPr>
+                                          </m:ctrlPr>
+                                        </m:sSubPr>
+                                        <m:e>
+                                          <m:r>
+                                            <a:rPr lang="en-US" i="1" smtClean="0">
+                                              <a:latin typeface="Cambria Math" panose="02040503050406030204" pitchFamily="18" charset="0"/>
+                                            </a:rPr>
+                                            <m:t>𝜖</m:t>
+                                          </m:r>
+                                        </m:e>
+                                        <m:sub>
+                                          <m:r>
+                                            <a:rPr lang="en-US" i="1" smtClean="0">
+                                              <a:latin typeface="Cambria Math" panose="02040503050406030204" pitchFamily="18" charset="0"/>
+                                            </a:rPr>
+                                            <m:t>𝑏</m:t>
+                                          </m:r>
+                                        </m:sub>
+                                      </m:sSub>
+                                    </m:num>
+                                    <m:den>
+                                      <m:r>
+                                        <a:rPr lang="en-US" i="1" smtClean="0">
+                                          <a:latin typeface="Cambria Math" panose="02040503050406030204" pitchFamily="18" charset="0"/>
+                                        </a:rPr>
+                                        <m:t>1+</m:t>
+                                      </m:r>
+                                      <m:sSub>
+                                        <m:sSubPr>
+                                          <m:ctrlPr>
+                                            <a:rPr lang="en-US" i="1" smtClean="0">
+                                              <a:latin typeface="Cambria Math" panose="02040503050406030204" pitchFamily="18" charset="0"/>
+                                            </a:rPr>
+                                          </m:ctrlPr>
+                                        </m:sSubPr>
+                                        <m:e>
+                                          <m:r>
+                                            <a:rPr lang="en-US" i="1" smtClean="0">
+                                              <a:latin typeface="Cambria Math" panose="02040503050406030204" pitchFamily="18" charset="0"/>
+                                            </a:rPr>
+                                            <m:t>𝜖</m:t>
+                                          </m:r>
+                                        </m:e>
+                                        <m:sub>
+                                          <m:r>
+                                            <a:rPr lang="en-US" i="1" smtClean="0">
+                                              <a:latin typeface="Cambria Math" panose="02040503050406030204" pitchFamily="18" charset="0"/>
+                                            </a:rPr>
+                                            <m:t>𝑝</m:t>
+                                          </m:r>
+                                        </m:sub>
+                                      </m:sSub>
+                                    </m:den>
+                                  </m:f>
+                                </m:e>
+                              </m:d>
+                            </m:e>
+                            <m:sup>
+                              <m:r>
+                                <a:rPr lang="en-US" i="1" smtClean="0">
+                                  <a:latin typeface="Cambria Math" panose="02040503050406030204" pitchFamily="18" charset="0"/>
+                                </a:rPr>
+                                <m:t>2</m:t>
+                              </m:r>
+                            </m:sup>
+                          </m:sSup>
+                          <m:r>
+                            <a:rPr lang="en-US" i="1" smtClean="0">
+                              <a:latin typeface="Cambria Math" panose="02040503050406030204" pitchFamily="18" charset="0"/>
+                            </a:rPr>
+                            <m:t>−1</m:t>
+                          </m:r>
+                        </m:e>
+                      </m:rad>
+                    </m:oMath>
+                  </m:oMathPara>
+                </a14:m>
+                <a:endParaRPr lang="en-US" dirty="0"/>
+              </a:p>
+            </p:txBody>
+          </p:sp>
+        </mc:Choice>
+        <mc:Fallback>
+          <p:sp>
+            <p:nvSpPr>
+              <p:cNvPr id="7" name="TextBox 6">
+                <a:extLst>
+                  <a:ext uri="{FF2B5EF4-FFF2-40B4-BE49-F238E27FC236}">
+                    <a16:creationId xmlns:a16="http://schemas.microsoft.com/office/drawing/2014/main" id="{76FC0351-B8FE-03D7-ECAE-8DACBD7AD296}"/>
+                  </a:ext>
+                </a:extLst>
+              </p:cNvPr>
+              <p:cNvSpPr txBox="1">
+                <a:spLocks noRot="1" noChangeAspect="1" noMove="1" noResize="1" noEditPoints="1" noAdjustHandles="1" noChangeArrowheads="1" noChangeShapeType="1" noTextEdit="1"/>
+              </p:cNvSpPr>
+              <p:nvPr/>
+            </p:nvSpPr>
+            <p:spPr>
+              <a:xfrm>
+                <a:off x="1370702" y="5362313"/>
+                <a:ext cx="2979534" cy="818366"/>
+              </a:xfrm>
+              <a:prstGeom prst="rect">
+                <a:avLst/>
+              </a:prstGeom>
+              <a:blipFill>
+                <a:blip r:embed="rId5"/>
+                <a:stretch>
+                  <a:fillRect l="-426" r="-1277" b="-1538"/>
+                </a:stretch>
+              </a:blipFill>
+            </p:spPr>
+            <p:txBody>
+              <a:bodyPr/>
+              <a:lstStyle/>
+              <a:p>
+                <a:r>
+                  <a:rPr lang="en-US">
+                    <a:noFill/>
+                  </a:rPr>
+                  <a:t> </a:t>
+                </a:r>
+              </a:p>
+            </p:txBody>
+          </p:sp>
+        </mc:Fallback>
+      </mc:AlternateContent>
+      <mc:AlternateContent xmlns:mc="http://schemas.openxmlformats.org/markup-compatibility/2006">
+        <mc:Choice xmlns:a14="http://schemas.microsoft.com/office/drawing/2010/main" Requires="a14">
+          <p:sp>
+            <p:nvSpPr>
+              <p:cNvPr id="9" name="TextBox 8">
+                <a:extLst>
+                  <a:ext uri="{FF2B5EF4-FFF2-40B4-BE49-F238E27FC236}">
+                    <a16:creationId xmlns:a16="http://schemas.microsoft.com/office/drawing/2014/main" id="{4C016E25-65EF-3C22-7F49-99EE69AC3F08}"/>
+                  </a:ext>
+                </a:extLst>
+              </p:cNvPr>
+              <p:cNvSpPr txBox="1"/>
+              <p:nvPr/>
+            </p:nvSpPr>
+            <p:spPr>
+              <a:xfrm>
+                <a:off x="5380245" y="4202658"/>
+                <a:ext cx="3088859" cy="276999"/>
+              </a:xfrm>
+              <a:prstGeom prst="rect">
+                <a:avLst/>
+              </a:prstGeom>
+              <a:noFill/>
+            </p:spPr>
+            <p:txBody>
+              <a:bodyPr wrap="none" lIns="0" tIns="0" rIns="0" bIns="0" rtlCol="0">
+                <a:spAutoFit/>
+              </a:bodyPr>
+              <a:lstStyle/>
+              <a:p>
+                <a14:m>
+                  <m:oMathPara xmlns:m="http://schemas.openxmlformats.org/officeDocument/2006/math">
+                    <m:oMathParaPr>
+                      <m:jc m:val="centerGroup"/>
+                    </m:oMathParaPr>
+                    <m:oMath xmlns:m="http://schemas.openxmlformats.org/officeDocument/2006/math">
+                      <m:r>
+                        <m:rPr>
+                          <m:sty m:val="p"/>
+                        </m:rPr>
+                        <a:rPr lang="en-US" b="0" i="1" smtClean="0">
+                          <a:latin typeface="Cambria Math" panose="02040503050406030204" pitchFamily="18" charset="0"/>
+                        </a:rPr>
+                        <m:t>Pentru</m:t>
+                      </m:r>
+                      <m:r>
+                        <a:rPr lang="en-US" b="0" i="1" smtClean="0">
+                          <a:latin typeface="Cambria Math" panose="02040503050406030204" pitchFamily="18" charset="0"/>
+                        </a:rPr>
+                        <m:t> </m:t>
+                      </m:r>
+                      <m:r>
+                        <m:rPr>
+                          <m:sty m:val="p"/>
+                        </m:rPr>
+                        <a:rPr lang="en-US" b="0" i="1" smtClean="0">
+                          <a:latin typeface="Cambria Math" panose="02040503050406030204" pitchFamily="18" charset="0"/>
+                        </a:rPr>
+                        <m:t>firul</m:t>
+                      </m:r>
+                      <m:r>
+                        <a:rPr lang="en-US" b="0" i="1" smtClean="0">
+                          <a:latin typeface="Cambria Math" panose="02040503050406030204" pitchFamily="18" charset="0"/>
+                        </a:rPr>
+                        <m:t> </m:t>
+                      </m:r>
+                      <m:r>
+                        <m:rPr>
+                          <m:sty m:val="p"/>
+                        </m:rPr>
+                        <a:rPr lang="en-US" b="0" i="1" smtClean="0">
+                          <a:latin typeface="Cambria Math" panose="02040503050406030204" pitchFamily="18" charset="0"/>
+                        </a:rPr>
+                        <m:t>intern</m:t>
+                      </m:r>
+                      <m:r>
+                        <a:rPr lang="en-US" b="0" i="1" smtClean="0">
+                          <a:latin typeface="Cambria Math" panose="02040503050406030204" pitchFamily="18" charset="0"/>
+                        </a:rPr>
+                        <m:t> </m:t>
+                      </m:r>
+                      <m:sSub>
+                        <m:sSubPr>
+                          <m:ctrlPr>
+                            <a:rPr lang="en-US" b="0" i="1" smtClean="0">
+                              <a:latin typeface="Cambria Math" panose="02040503050406030204" pitchFamily="18" charset="0"/>
+                            </a:rPr>
+                          </m:ctrlPr>
+                        </m:sSubPr>
+                        <m:e>
+                          <m:r>
+                            <a:rPr lang="en-US" b="0" i="1" smtClean="0">
+                              <a:latin typeface="Cambria Math" panose="02040503050406030204" pitchFamily="18" charset="0"/>
+                              <a:ea typeface="Cambria Math" panose="02040503050406030204" pitchFamily="18" charset="0"/>
+                            </a:rPr>
+                            <m:t>𝜖</m:t>
+                          </m:r>
+                        </m:e>
+                        <m:sub>
+                          <m:r>
+                            <m:rPr>
+                              <m:sty m:val="p"/>
+                            </m:rPr>
+                            <a:rPr lang="en-US" b="0" i="1" smtClean="0">
+                              <a:latin typeface="Cambria Math" panose="02040503050406030204" pitchFamily="18" charset="0"/>
+                            </a:rPr>
+                            <m:t>i</m:t>
+                          </m:r>
+                        </m:sub>
+                      </m:sSub>
+                      <m:r>
+                        <a:rPr lang="en-US" b="0" i="1" smtClean="0">
+                          <a:latin typeface="Cambria Math" panose="02040503050406030204" pitchFamily="18" charset="0"/>
+                        </a:rPr>
+                        <m:t>≈0.22 </m:t>
+                      </m:r>
+                      <m:sSub>
+                        <m:sSubPr>
+                          <m:ctrlPr>
+                            <a:rPr lang="en-US" i="1">
+                              <a:latin typeface="Cambria Math" panose="02040503050406030204" pitchFamily="18" charset="0"/>
+                            </a:rPr>
+                          </m:ctrlPr>
+                        </m:sSubPr>
+                        <m:e>
+                          <m:r>
+                            <a:rPr lang="en-US" i="1">
+                              <a:latin typeface="Cambria Math" panose="02040503050406030204" pitchFamily="18" charset="0"/>
+                              <a:ea typeface="Cambria Math" panose="02040503050406030204" pitchFamily="18" charset="0"/>
+                            </a:rPr>
+                            <m:t>𝜖</m:t>
+                          </m:r>
+                        </m:e>
+                        <m:sub>
+                          <m:r>
+                            <m:rPr>
+                              <m:sty m:val="p"/>
+                            </m:rPr>
+                            <a:rPr lang="en-US" b="0" i="1" smtClean="0">
+                              <a:latin typeface="Cambria Math" panose="02040503050406030204" pitchFamily="18" charset="0"/>
+                              <a:ea typeface="Cambria Math" panose="02040503050406030204" pitchFamily="18" charset="0"/>
+                            </a:rPr>
+                            <m:t>b</m:t>
+                          </m:r>
+                        </m:sub>
+                      </m:sSub>
+                    </m:oMath>
+                  </m:oMathPara>
+                </a14:m>
+                <a:endParaRPr lang="en-US" dirty="0"/>
+              </a:p>
+            </p:txBody>
+          </p:sp>
+        </mc:Choice>
+        <mc:Fallback>
+          <p:sp>
+            <p:nvSpPr>
+              <p:cNvPr id="9" name="TextBox 8">
+                <a:extLst>
+                  <a:ext uri="{FF2B5EF4-FFF2-40B4-BE49-F238E27FC236}">
+                    <a16:creationId xmlns:a16="http://schemas.microsoft.com/office/drawing/2014/main" id="{4C016E25-65EF-3C22-7F49-99EE69AC3F08}"/>
+                  </a:ext>
+                </a:extLst>
+              </p:cNvPr>
+              <p:cNvSpPr txBox="1">
+                <a:spLocks noRot="1" noChangeAspect="1" noMove="1" noResize="1" noEditPoints="1" noAdjustHandles="1" noChangeArrowheads="1" noChangeShapeType="1" noTextEdit="1"/>
+              </p:cNvSpPr>
+              <p:nvPr/>
+            </p:nvSpPr>
+            <p:spPr>
+              <a:xfrm>
+                <a:off x="5380245" y="4202658"/>
+                <a:ext cx="3088859" cy="276999"/>
+              </a:xfrm>
+              <a:prstGeom prst="rect">
+                <a:avLst/>
+              </a:prstGeom>
+              <a:blipFill>
+                <a:blip r:embed="rId6"/>
+                <a:stretch>
+                  <a:fillRect l="-1230" r="-410" b="-39130"/>
+                </a:stretch>
+              </a:blipFill>
+            </p:spPr>
+            <p:txBody>
+              <a:bodyPr/>
+              <a:lstStyle/>
+              <a:p>
+                <a:r>
+                  <a:rPr lang="en-US">
+                    <a:noFill/>
+                  </a:rPr>
+                  <a:t> </a:t>
+                </a:r>
+              </a:p>
+            </p:txBody>
+          </p:sp>
+        </mc:Fallback>
+      </mc:AlternateContent>
+      <mc:AlternateContent xmlns:mc="http://schemas.openxmlformats.org/markup-compatibility/2006">
+        <mc:Choice xmlns:a14="http://schemas.microsoft.com/office/drawing/2010/main" Requires="a14">
+          <p:sp>
+            <p:nvSpPr>
+              <p:cNvPr id="11" name="TextBox 10">
+                <a:extLst>
+                  <a:ext uri="{FF2B5EF4-FFF2-40B4-BE49-F238E27FC236}">
+                    <a16:creationId xmlns:a16="http://schemas.microsoft.com/office/drawing/2014/main" id="{B08515E2-A28D-E931-13EA-72762154E39B}"/>
+                  </a:ext>
+                </a:extLst>
+              </p:cNvPr>
+              <p:cNvSpPr txBox="1"/>
+              <p:nvPr/>
+            </p:nvSpPr>
+            <p:spPr>
+              <a:xfrm>
+                <a:off x="5380245" y="4744025"/>
+                <a:ext cx="3261983" cy="276999"/>
+              </a:xfrm>
+              <a:prstGeom prst="rect">
+                <a:avLst/>
+              </a:prstGeom>
+              <a:noFill/>
+            </p:spPr>
+            <p:txBody>
+              <a:bodyPr wrap="none" lIns="0" tIns="0" rIns="0" bIns="0" rtlCol="0">
+                <a:spAutoFit/>
+              </a:bodyPr>
+              <a:lstStyle/>
+              <a:p>
+                <a14:m>
+                  <m:oMathPara xmlns:m="http://schemas.openxmlformats.org/officeDocument/2006/math">
+                    <m:oMathParaPr>
+                      <m:jc m:val="centerGroup"/>
+                    </m:oMathParaPr>
+                    <m:oMath xmlns:m="http://schemas.openxmlformats.org/officeDocument/2006/math">
+                      <m:r>
+                        <m:rPr>
+                          <m:sty m:val="p"/>
+                        </m:rPr>
+                        <a:rPr lang="en-US" b="0" i="1" smtClean="0">
+                          <a:latin typeface="Cambria Math" panose="02040503050406030204" pitchFamily="18" charset="0"/>
+                        </a:rPr>
+                        <m:t>Pentru</m:t>
+                      </m:r>
+                      <m:r>
+                        <a:rPr lang="en-US" b="0" i="1" smtClean="0">
+                          <a:latin typeface="Cambria Math" panose="02040503050406030204" pitchFamily="18" charset="0"/>
+                        </a:rPr>
+                        <m:t> </m:t>
+                      </m:r>
+                      <m:r>
+                        <m:rPr>
+                          <m:sty m:val="p"/>
+                        </m:rPr>
+                        <a:rPr lang="en-US" b="0" i="1" smtClean="0">
+                          <a:latin typeface="Cambria Math" panose="02040503050406030204" pitchFamily="18" charset="0"/>
+                        </a:rPr>
+                        <m:t>firele</m:t>
+                      </m:r>
+                      <m:r>
+                        <a:rPr lang="en-US" b="0" i="1" smtClean="0">
+                          <a:latin typeface="Cambria Math" panose="02040503050406030204" pitchFamily="18" charset="0"/>
+                        </a:rPr>
+                        <m:t> </m:t>
+                      </m:r>
+                      <m:r>
+                        <m:rPr>
+                          <m:sty m:val="p"/>
+                        </m:rPr>
+                        <a:rPr lang="en-US" b="0" i="1" smtClean="0">
+                          <a:latin typeface="Cambria Math" panose="02040503050406030204" pitchFamily="18" charset="0"/>
+                        </a:rPr>
+                        <m:t>radiale</m:t>
+                      </m:r>
+                      <m:r>
+                        <a:rPr lang="en-US" b="0" i="1" smtClean="0">
+                          <a:latin typeface="Cambria Math" panose="02040503050406030204" pitchFamily="18" charset="0"/>
+                        </a:rPr>
+                        <m:t> </m:t>
+                      </m:r>
+                      <m:sSub>
+                        <m:sSubPr>
+                          <m:ctrlPr>
+                            <a:rPr lang="en-US" b="0" i="1" smtClean="0">
+                              <a:latin typeface="Cambria Math" panose="02040503050406030204" pitchFamily="18" charset="0"/>
+                            </a:rPr>
+                          </m:ctrlPr>
+                        </m:sSubPr>
+                        <m:e>
+                          <m:r>
+                            <a:rPr lang="en-US" b="0" i="1" smtClean="0">
+                              <a:latin typeface="Cambria Math" panose="02040503050406030204" pitchFamily="18" charset="0"/>
+                              <a:ea typeface="Cambria Math" panose="02040503050406030204" pitchFamily="18" charset="0"/>
+                            </a:rPr>
+                            <m:t>𝜖</m:t>
+                          </m:r>
+                        </m:e>
+                        <m:sub>
+                          <m:r>
+                            <m:rPr>
+                              <m:sty m:val="p"/>
+                            </m:rPr>
+                            <a:rPr lang="en-US" b="0" i="1" smtClean="0">
+                              <a:latin typeface="Cambria Math" panose="02040503050406030204" pitchFamily="18" charset="0"/>
+                            </a:rPr>
+                            <m:t>i</m:t>
+                          </m:r>
+                        </m:sub>
+                      </m:sSub>
+                      <m:r>
+                        <a:rPr lang="en-US" i="1">
+                          <a:latin typeface="Cambria Math" panose="02040503050406030204" pitchFamily="18" charset="0"/>
+                          <a:ea typeface="Cambria Math" panose="02040503050406030204" pitchFamily="18" charset="0"/>
+                        </a:rPr>
+                        <m:t>≤</m:t>
+                      </m:r>
+                      <m:r>
+                        <a:rPr lang="en-US" b="0" i="1" smtClean="0">
+                          <a:latin typeface="Cambria Math" panose="02040503050406030204" pitchFamily="18" charset="0"/>
+                        </a:rPr>
+                        <m:t>0.11 </m:t>
+                      </m:r>
+                      <m:sSub>
+                        <m:sSubPr>
+                          <m:ctrlPr>
+                            <a:rPr lang="en-US" i="1">
+                              <a:latin typeface="Cambria Math" panose="02040503050406030204" pitchFamily="18" charset="0"/>
+                            </a:rPr>
+                          </m:ctrlPr>
+                        </m:sSubPr>
+                        <m:e>
+                          <m:r>
+                            <a:rPr lang="en-US" i="1">
+                              <a:latin typeface="Cambria Math" panose="02040503050406030204" pitchFamily="18" charset="0"/>
+                              <a:ea typeface="Cambria Math" panose="02040503050406030204" pitchFamily="18" charset="0"/>
+                            </a:rPr>
+                            <m:t>𝜖</m:t>
+                          </m:r>
+                        </m:e>
+                        <m:sub>
+                          <m:r>
+                            <m:rPr>
+                              <m:sty m:val="p"/>
+                            </m:rPr>
+                            <a:rPr lang="en-US" b="0" i="1" smtClean="0">
+                              <a:latin typeface="Cambria Math" panose="02040503050406030204" pitchFamily="18" charset="0"/>
+                              <a:ea typeface="Cambria Math" panose="02040503050406030204" pitchFamily="18" charset="0"/>
+                            </a:rPr>
+                            <m:t>b</m:t>
+                          </m:r>
+                        </m:sub>
+                      </m:sSub>
+                    </m:oMath>
+                  </m:oMathPara>
+                </a14:m>
+                <a:endParaRPr lang="en-US" dirty="0"/>
+              </a:p>
+            </p:txBody>
+          </p:sp>
+        </mc:Choice>
+        <mc:Fallback>
+          <p:sp>
+            <p:nvSpPr>
+              <p:cNvPr id="11" name="TextBox 10">
+                <a:extLst>
+                  <a:ext uri="{FF2B5EF4-FFF2-40B4-BE49-F238E27FC236}">
+                    <a16:creationId xmlns:a16="http://schemas.microsoft.com/office/drawing/2014/main" id="{B08515E2-A28D-E931-13EA-72762154E39B}"/>
+                  </a:ext>
+                </a:extLst>
+              </p:cNvPr>
+              <p:cNvSpPr txBox="1">
+                <a:spLocks noRot="1" noChangeAspect="1" noMove="1" noResize="1" noEditPoints="1" noAdjustHandles="1" noChangeArrowheads="1" noChangeShapeType="1" noTextEdit="1"/>
+              </p:cNvSpPr>
+              <p:nvPr/>
+            </p:nvSpPr>
+            <p:spPr>
+              <a:xfrm>
+                <a:off x="5380245" y="4744025"/>
+                <a:ext cx="3261983" cy="276999"/>
+              </a:xfrm>
+              <a:prstGeom prst="rect">
+                <a:avLst/>
+              </a:prstGeom>
+              <a:blipFill>
+                <a:blip r:embed="rId7"/>
+                <a:stretch>
+                  <a:fillRect l="-1163" t="-4348" b="-39130"/>
+                </a:stretch>
+              </a:blipFill>
+            </p:spPr>
+            <p:txBody>
+              <a:bodyPr/>
+              <a:lstStyle/>
+              <a:p>
+                <a:r>
+                  <a:rPr lang="en-US">
+                    <a:noFill/>
+                  </a:rPr>
+                  <a:t> </a:t>
+                </a:r>
+              </a:p>
+            </p:txBody>
+          </p:sp>
+        </mc:Fallback>
+      </mc:AlternateContent>
+      <mc:AlternateContent xmlns:mc="http://schemas.openxmlformats.org/markup-compatibility/2006">
+        <mc:Choice xmlns:a14="http://schemas.microsoft.com/office/drawing/2010/main" Requires="a14">
+          <p:sp>
+            <p:nvSpPr>
+              <p:cNvPr id="13" name="TextBox 12">
+                <a:extLst>
+                  <a:ext uri="{FF2B5EF4-FFF2-40B4-BE49-F238E27FC236}">
+                    <a16:creationId xmlns:a16="http://schemas.microsoft.com/office/drawing/2014/main" id="{FB006393-FEBB-544A-ED5A-E413FE57AEBC}"/>
+                  </a:ext>
+                </a:extLst>
+              </p:cNvPr>
+              <p:cNvSpPr txBox="1"/>
+              <p:nvPr/>
+            </p:nvSpPr>
+            <p:spPr>
+              <a:xfrm>
+                <a:off x="5463600" y="5323286"/>
+                <a:ext cx="3095271" cy="582275"/>
+              </a:xfrm>
+              <a:prstGeom prst="rect">
+                <a:avLst/>
+              </a:prstGeom>
+              <a:noFill/>
+            </p:spPr>
+            <p:txBody>
+              <a:bodyPr wrap="none" lIns="0" tIns="0" rIns="0" bIns="0" rtlCol="0">
+                <a:spAutoFit/>
+              </a:bodyPr>
+              <a:lstStyle/>
+              <a:p>
+                <a14:m>
+                  <m:oMathPara xmlns:m="http://schemas.openxmlformats.org/officeDocument/2006/math">
+                    <m:oMathParaPr>
+                      <m:jc m:val="centerGroup"/>
+                    </m:oMathParaPr>
+                    <m:oMath xmlns:m="http://schemas.openxmlformats.org/officeDocument/2006/math">
+                      <m:r>
+                        <a:rPr lang="en-US" i="1" smtClean="0">
+                          <a:latin typeface="Cambria Math" panose="02040503050406030204" pitchFamily="18" charset="0"/>
+                          <a:ea typeface="Cambria Math" panose="02040503050406030204" pitchFamily="18" charset="0"/>
+                        </a:rPr>
+                        <m:t>𝜂</m:t>
+                      </m:r>
+                      <m:r>
+                        <a:rPr lang="en-US" i="1" smtClean="0">
+                          <a:latin typeface="Cambria Math" panose="02040503050406030204" pitchFamily="18" charset="0"/>
+                        </a:rPr>
+                        <m:t>=</m:t>
+                      </m:r>
+                      <m:f>
+                        <m:fPr>
+                          <m:ctrlPr>
+                            <a:rPr lang="en-US" i="1" smtClean="0">
+                              <a:latin typeface="Cambria Math" panose="02040503050406030204" pitchFamily="18" charset="0"/>
+                            </a:rPr>
+                          </m:ctrlPr>
+                        </m:fPr>
+                        <m:num>
+                          <m:sSub>
+                            <m:sSubPr>
+                              <m:ctrlPr>
+                                <a:rPr lang="en-US" i="1" smtClean="0">
+                                  <a:latin typeface="Cambria Math" panose="02040503050406030204" pitchFamily="18" charset="0"/>
+                                </a:rPr>
+                              </m:ctrlPr>
+                            </m:sSubPr>
+                            <m:e>
+                              <m:r>
+                                <m:rPr>
+                                  <m:sty m:val="p"/>
+                                </m:rPr>
+                                <a:rPr lang="en-US" b="0" i="1" smtClean="0">
+                                  <a:latin typeface="Cambria Math" panose="02040503050406030204" pitchFamily="18" charset="0"/>
+                                </a:rPr>
+                                <m:t>U</m:t>
+                              </m:r>
+                            </m:e>
+                            <m:sub>
+                              <m:r>
+                                <m:rPr>
+                                  <m:sty m:val="p"/>
+                                </m:rPr>
+                                <a:rPr lang="en-US" b="0" i="1" smtClean="0">
+                                  <a:latin typeface="Cambria Math" panose="02040503050406030204" pitchFamily="18" charset="0"/>
+                                </a:rPr>
+                                <m:t>net</m:t>
+                              </m:r>
+                            </m:sub>
+                          </m:sSub>
+                        </m:num>
+                        <m:den>
+                          <m:sSub>
+                            <m:sSubPr>
+                              <m:ctrlPr>
+                                <a:rPr lang="en-US" i="1" smtClean="0">
+                                  <a:latin typeface="Cambria Math" panose="02040503050406030204" pitchFamily="18" charset="0"/>
+                                </a:rPr>
+                              </m:ctrlPr>
+                            </m:sSubPr>
+                            <m:e>
+                              <m:r>
+                                <m:rPr>
+                                  <m:sty m:val="p"/>
+                                </m:rPr>
+                                <a:rPr lang="en-US" b="0" i="1" smtClean="0">
+                                  <a:latin typeface="Cambria Math" panose="02040503050406030204" pitchFamily="18" charset="0"/>
+                                </a:rPr>
+                                <m:t>m</m:t>
+                              </m:r>
+                            </m:e>
+                            <m:sub>
+                              <m:r>
+                                <m:rPr>
+                                  <m:sty m:val="p"/>
+                                </m:rPr>
+                                <a:rPr lang="en-US" b="0" i="1" smtClean="0">
+                                  <a:latin typeface="Cambria Math" panose="02040503050406030204" pitchFamily="18" charset="0"/>
+                                </a:rPr>
+                                <m:t>net</m:t>
+                              </m:r>
+                            </m:sub>
+                          </m:sSub>
+                          <m:r>
+                            <a:rPr lang="en-US" i="1" smtClean="0">
+                              <a:latin typeface="Cambria Math" panose="02040503050406030204" pitchFamily="18" charset="0"/>
+                            </a:rPr>
+                            <m:t>⋅</m:t>
+                          </m:r>
+                          <m:sSub>
+                            <m:sSubPr>
+                              <m:ctrlPr>
+                                <a:rPr lang="en-US" i="1" smtClean="0">
+                                  <a:latin typeface="Cambria Math" panose="02040503050406030204" pitchFamily="18" charset="0"/>
+                                </a:rPr>
+                              </m:ctrlPr>
+                            </m:sSubPr>
+                            <m:e>
+                              <m:r>
+                                <a:rPr lang="en-US" b="0" i="1" smtClean="0">
+                                  <a:latin typeface="Cambria Math" panose="02040503050406030204" pitchFamily="18" charset="0"/>
+                                </a:rPr>
+                                <m:t>𝑒</m:t>
+                              </m:r>
+                            </m:e>
+                            <m:sub>
+                              <m:r>
+                                <m:rPr>
+                                  <m:sty m:val="p"/>
+                                </m:rPr>
+                                <a:rPr lang="en-US" b="0" i="1" smtClean="0">
+                                  <a:latin typeface="Cambria Math" panose="02040503050406030204" pitchFamily="18" charset="0"/>
+                                </a:rPr>
+                                <m:t>mat</m:t>
+                              </m:r>
+                            </m:sub>
+                          </m:sSub>
+                        </m:den>
+                      </m:f>
+                      <m:r>
+                        <a:rPr lang="en-US" b="0" i="1" smtClean="0">
+                          <a:latin typeface="Cambria Math" panose="02040503050406030204" pitchFamily="18" charset="0"/>
+                        </a:rPr>
+                        <m:t>=</m:t>
+                      </m:r>
+                      <m:f>
+                        <m:fPr>
+                          <m:ctrlPr>
+                            <a:rPr lang="en-US" i="1">
+                              <a:latin typeface="Cambria Math" panose="02040503050406030204" pitchFamily="18" charset="0"/>
+                            </a:rPr>
+                          </m:ctrlPr>
+                        </m:fPr>
+                        <m:num>
+                          <m:nary>
+                            <m:naryPr>
+                              <m:chr m:val="∑"/>
+                              <m:limLoc m:val="subSup"/>
+                              <m:supHide m:val="on"/>
+                              <m:ctrlPr>
+                                <a:rPr lang="en-US" i="1" smtClean="0">
+                                  <a:latin typeface="Cambria Math" panose="02040503050406030204" pitchFamily="18" charset="0"/>
+                                </a:rPr>
+                              </m:ctrlPr>
+                            </m:naryPr>
+                            <m:sub>
+                              <m:r>
+                                <m:rPr>
+                                  <m:sty m:val="p"/>
+                                  <m:brk m:alnAt="9"/>
+                                </m:rPr>
+                                <a:rPr lang="en-US" b="0" i="1" smtClean="0">
+                                  <a:latin typeface="Cambria Math" panose="02040503050406030204" pitchFamily="18" charset="0"/>
+                                </a:rPr>
+                                <m:t>threads</m:t>
+                              </m:r>
+                            </m:sub>
+                            <m:sup/>
+                            <m:e>
+                              <m:sSub>
+                                <m:sSubPr>
+                                  <m:ctrlPr>
+                                    <a:rPr lang="en-US" i="1" smtClean="0">
+                                      <a:latin typeface="Cambria Math" panose="02040503050406030204" pitchFamily="18" charset="0"/>
+                                    </a:rPr>
+                                  </m:ctrlPr>
+                                </m:sSubPr>
+                                <m:e>
+                                  <m:r>
+                                    <m:rPr>
+                                      <m:sty m:val="p"/>
+                                    </m:rPr>
+                                    <a:rPr lang="en-US" b="0" i="1" smtClean="0">
+                                      <a:latin typeface="Cambria Math" panose="02040503050406030204" pitchFamily="18" charset="0"/>
+                                    </a:rPr>
+                                    <m:t>U</m:t>
+                                  </m:r>
+                                </m:e>
+                                <m:sub>
+                                  <m:r>
+                                    <m:rPr>
+                                      <m:sty m:val="p"/>
+                                    </m:rPr>
+                                    <a:rPr lang="en-US" b="0" i="1" smtClean="0">
+                                      <a:latin typeface="Cambria Math" panose="02040503050406030204" pitchFamily="18" charset="0"/>
+                                    </a:rPr>
+                                    <m:t>thr</m:t>
+                                  </m:r>
+                                </m:sub>
+                              </m:sSub>
+                            </m:e>
+                          </m:nary>
+                        </m:num>
+                        <m:den>
+                          <m:sSub>
+                            <m:sSubPr>
+                              <m:ctrlPr>
+                                <a:rPr lang="en-US" i="1">
+                                  <a:latin typeface="Cambria Math" panose="02040503050406030204" pitchFamily="18" charset="0"/>
+                                </a:rPr>
+                              </m:ctrlPr>
+                            </m:sSubPr>
+                            <m:e>
+                              <m:r>
+                                <m:rPr>
+                                  <m:sty m:val="p"/>
+                                </m:rPr>
+                                <a:rPr lang="en-US" b="0" i="1" smtClean="0">
+                                  <a:latin typeface="Cambria Math" panose="02040503050406030204" pitchFamily="18" charset="0"/>
+                                </a:rPr>
+                                <m:t>V</m:t>
+                              </m:r>
+                            </m:e>
+                            <m:sub>
+                              <m:r>
+                                <m:rPr>
+                                  <m:sty m:val="p"/>
+                                </m:rPr>
+                                <a:rPr lang="en-US" b="0" i="1" smtClean="0">
+                                  <a:latin typeface="Cambria Math" panose="02040503050406030204" pitchFamily="18" charset="0"/>
+                                </a:rPr>
+                                <m:t>tot</m:t>
+                              </m:r>
+                            </m:sub>
+                          </m:sSub>
+                          <m:r>
+                            <a:rPr lang="en-US" i="1">
+                              <a:latin typeface="Cambria Math" panose="02040503050406030204" pitchFamily="18" charset="0"/>
+                            </a:rPr>
+                            <m:t>⋅</m:t>
+                          </m:r>
+                          <m:r>
+                            <a:rPr lang="en-US" i="1" smtClean="0">
+                              <a:latin typeface="Cambria Math" panose="02040503050406030204" pitchFamily="18" charset="0"/>
+                              <a:ea typeface="Cambria Math" panose="02040503050406030204" pitchFamily="18" charset="0"/>
+                            </a:rPr>
+                            <m:t>𝜙</m:t>
+                          </m:r>
+                          <m:r>
+                            <a:rPr lang="en-US" b="0" i="1" smtClean="0">
+                              <a:latin typeface="Cambria Math" panose="02040503050406030204" pitchFamily="18" charset="0"/>
+                              <a:ea typeface="Cambria Math" panose="02040503050406030204" pitchFamily="18" charset="0"/>
+                            </a:rPr>
+                            <m:t>(</m:t>
+                          </m:r>
+                          <m:sSub>
+                            <m:sSubPr>
+                              <m:ctrlPr>
+                                <a:rPr lang="en-US" b="0" i="1" smtClean="0">
+                                  <a:latin typeface="Cambria Math" panose="02040503050406030204" pitchFamily="18" charset="0"/>
+                                  <a:ea typeface="Cambria Math" panose="02040503050406030204" pitchFamily="18" charset="0"/>
+                                </a:rPr>
+                              </m:ctrlPr>
+                            </m:sSubPr>
+                            <m:e>
+                              <m:r>
+                                <a:rPr lang="en-US" b="0" i="1" smtClean="0">
+                                  <a:latin typeface="Cambria Math" panose="02040503050406030204" pitchFamily="18" charset="0"/>
+                                  <a:ea typeface="Cambria Math" panose="02040503050406030204" pitchFamily="18" charset="0"/>
+                                </a:rPr>
+                                <m:t>𝜖</m:t>
+                              </m:r>
+                            </m:e>
+                            <m:sub>
+                              <m:r>
+                                <m:rPr>
+                                  <m:sty m:val="p"/>
+                                </m:rPr>
+                                <a:rPr lang="en-US" b="0" i="1" smtClean="0">
+                                  <a:latin typeface="Cambria Math" panose="02040503050406030204" pitchFamily="18" charset="0"/>
+                                  <a:ea typeface="Cambria Math" panose="02040503050406030204" pitchFamily="18" charset="0"/>
+                                </a:rPr>
+                                <m:t>b</m:t>
+                              </m:r>
+                            </m:sub>
+                          </m:sSub>
+                          <m:r>
+                            <a:rPr lang="en-US" b="0" i="1" smtClean="0">
+                              <a:latin typeface="Cambria Math" panose="02040503050406030204" pitchFamily="18" charset="0"/>
+                              <a:ea typeface="Cambria Math" panose="02040503050406030204" pitchFamily="18" charset="0"/>
+                            </a:rPr>
+                            <m:t>)</m:t>
+                          </m:r>
+                        </m:den>
+                      </m:f>
+                    </m:oMath>
+                  </m:oMathPara>
+                </a14:m>
+                <a:endParaRPr lang="en-US" dirty="0"/>
+              </a:p>
+            </p:txBody>
+          </p:sp>
+        </mc:Choice>
+        <mc:Fallback>
+          <p:sp>
+            <p:nvSpPr>
+              <p:cNvPr id="13" name="TextBox 12">
+                <a:extLst>
+                  <a:ext uri="{FF2B5EF4-FFF2-40B4-BE49-F238E27FC236}">
+                    <a16:creationId xmlns:a16="http://schemas.microsoft.com/office/drawing/2014/main" id="{FB006393-FEBB-544A-ED5A-E413FE57AEBC}"/>
+                  </a:ext>
+                </a:extLst>
+              </p:cNvPr>
+              <p:cNvSpPr txBox="1">
+                <a:spLocks noRot="1" noChangeAspect="1" noMove="1" noResize="1" noEditPoints="1" noAdjustHandles="1" noChangeArrowheads="1" noChangeShapeType="1" noTextEdit="1"/>
+              </p:cNvSpPr>
+              <p:nvPr/>
+            </p:nvSpPr>
+            <p:spPr>
+              <a:xfrm>
+                <a:off x="5463600" y="5323286"/>
+                <a:ext cx="3095271" cy="582275"/>
+              </a:xfrm>
+              <a:prstGeom prst="rect">
+                <a:avLst/>
+              </a:prstGeom>
+              <a:blipFill>
+                <a:blip r:embed="rId8"/>
+                <a:stretch>
+                  <a:fillRect l="-1230" t="-80851" r="-410" b="-59574"/>
+                </a:stretch>
+              </a:blipFill>
+            </p:spPr>
+            <p:txBody>
+              <a:bodyPr/>
+              <a:lstStyle/>
+              <a:p>
+                <a:r>
+                  <a:rPr lang="en-US">
+                    <a:noFill/>
+                  </a:rPr>
+                  <a:t> </a:t>
+                </a:r>
+              </a:p>
+            </p:txBody>
+          </p:sp>
+        </mc:Fallback>
+      </mc:AlternateContent>
+      <mc:AlternateContent xmlns:mc="http://schemas.openxmlformats.org/markup-compatibility/2006">
+        <mc:Choice xmlns:a14="http://schemas.microsoft.com/office/drawing/2010/main" Requires="a14">
+          <p:sp>
+            <p:nvSpPr>
+              <p:cNvPr id="15" name="TextBox 14">
+                <a:extLst>
+                  <a:ext uri="{FF2B5EF4-FFF2-40B4-BE49-F238E27FC236}">
+                    <a16:creationId xmlns:a16="http://schemas.microsoft.com/office/drawing/2014/main" id="{F9BE932E-70BA-9B4C-D35C-29DFB39DCB62}"/>
+                  </a:ext>
+                </a:extLst>
+              </p:cNvPr>
+              <p:cNvSpPr txBox="1"/>
+              <p:nvPr/>
+            </p:nvSpPr>
+            <p:spPr>
+              <a:xfrm>
+                <a:off x="9312079" y="4202657"/>
+                <a:ext cx="1332031" cy="276999"/>
+              </a:xfrm>
+              <a:prstGeom prst="rect">
+                <a:avLst/>
+              </a:prstGeom>
+              <a:noFill/>
+            </p:spPr>
+            <p:txBody>
+              <a:bodyPr wrap="none" lIns="0" tIns="0" rIns="0" bIns="0" rtlCol="0">
+                <a:spAutoFit/>
+              </a:bodyPr>
+              <a:lstStyle/>
+              <a:p>
+                <a14:m>
+                  <m:oMathPara xmlns:m="http://schemas.openxmlformats.org/officeDocument/2006/math">
+                    <m:oMathParaPr>
+                      <m:jc m:val="centerGroup"/>
+                    </m:oMathParaPr>
+                    <m:oMath xmlns:m="http://schemas.openxmlformats.org/officeDocument/2006/math">
+                      <m:sSub>
+                        <m:sSubPr>
+                          <m:ctrlPr>
+                            <a:rPr lang="en-US" i="1" smtClean="0">
+                              <a:latin typeface="Cambria Math" panose="02040503050406030204" pitchFamily="18" charset="0"/>
+                              <a:ea typeface="Cambria Math" panose="02040503050406030204" pitchFamily="18" charset="0"/>
+                            </a:rPr>
+                          </m:ctrlPr>
+                        </m:sSubPr>
+                        <m:e>
+                          <m:r>
+                            <a:rPr lang="en-US" i="1" smtClean="0">
+                              <a:latin typeface="Cambria Math" panose="02040503050406030204" pitchFamily="18" charset="0"/>
+                              <a:ea typeface="Cambria Math" panose="02040503050406030204" pitchFamily="18" charset="0"/>
+                            </a:rPr>
+                            <m:t>𝜂</m:t>
+                          </m:r>
+                        </m:e>
+                        <m:sub>
+                          <m:r>
+                            <m:rPr>
+                              <m:sty m:val="p"/>
+                            </m:rPr>
+                            <a:rPr lang="en-US" b="0" i="1" smtClean="0">
+                              <a:latin typeface="Cambria Math" panose="02040503050406030204" pitchFamily="18" charset="0"/>
+                              <a:ea typeface="Cambria Math" panose="02040503050406030204" pitchFamily="18" charset="0"/>
+                            </a:rPr>
+                            <m:t>Lo</m:t>
+                          </m:r>
+                        </m:sub>
+                      </m:sSub>
+                      <m:r>
+                        <a:rPr lang="en-US" i="1" smtClean="0">
+                          <a:latin typeface="Cambria Math" panose="02040503050406030204" pitchFamily="18" charset="0"/>
+                          <a:ea typeface="Cambria Math" panose="02040503050406030204" pitchFamily="18" charset="0"/>
+                        </a:rPr>
+                        <m:t>≈</m:t>
+                      </m:r>
+                      <m:r>
+                        <a:rPr lang="en-US" b="0" i="1" smtClean="0">
+                          <a:latin typeface="Cambria Math" panose="02040503050406030204" pitchFamily="18" charset="0"/>
+                          <a:ea typeface="Cambria Math" panose="02040503050406030204" pitchFamily="18" charset="0"/>
+                        </a:rPr>
+                        <m:t>6.25%</m:t>
+                      </m:r>
+                    </m:oMath>
+                  </m:oMathPara>
+                </a14:m>
+                <a:endParaRPr lang="en-US" dirty="0"/>
+              </a:p>
+            </p:txBody>
+          </p:sp>
+        </mc:Choice>
+        <mc:Fallback>
+          <p:sp>
+            <p:nvSpPr>
+              <p:cNvPr id="15" name="TextBox 14">
+                <a:extLst>
+                  <a:ext uri="{FF2B5EF4-FFF2-40B4-BE49-F238E27FC236}">
+                    <a16:creationId xmlns:a16="http://schemas.microsoft.com/office/drawing/2014/main" id="{F9BE932E-70BA-9B4C-D35C-29DFB39DCB62}"/>
+                  </a:ext>
+                </a:extLst>
+              </p:cNvPr>
+              <p:cNvSpPr txBox="1">
+                <a:spLocks noRot="1" noChangeAspect="1" noMove="1" noResize="1" noEditPoints="1" noAdjustHandles="1" noChangeArrowheads="1" noChangeShapeType="1" noTextEdit="1"/>
+              </p:cNvSpPr>
+              <p:nvPr/>
+            </p:nvSpPr>
+            <p:spPr>
+              <a:xfrm>
+                <a:off x="9312079" y="4202657"/>
+                <a:ext cx="1332031" cy="276999"/>
+              </a:xfrm>
+              <a:prstGeom prst="rect">
+                <a:avLst/>
+              </a:prstGeom>
+              <a:blipFill>
+                <a:blip r:embed="rId9"/>
+                <a:stretch>
+                  <a:fillRect l="-3774" r="-3774" b="-30435"/>
+                </a:stretch>
+              </a:blipFill>
+            </p:spPr>
+            <p:txBody>
+              <a:bodyPr/>
+              <a:lstStyle/>
+              <a:p>
+                <a:r>
+                  <a:rPr lang="en-US">
+                    <a:noFill/>
+                  </a:rPr>
+                  <a:t> </a:t>
+                </a:r>
+              </a:p>
+            </p:txBody>
+          </p:sp>
+        </mc:Fallback>
+      </mc:AlternateContent>
+      <mc:AlternateContent xmlns:mc="http://schemas.openxmlformats.org/markup-compatibility/2006">
+        <mc:Choice xmlns:a14="http://schemas.microsoft.com/office/drawing/2010/main" Requires="a14">
+          <p:sp>
+            <p:nvSpPr>
+              <p:cNvPr id="16" name="TextBox 15">
+                <a:extLst>
+                  <a:ext uri="{FF2B5EF4-FFF2-40B4-BE49-F238E27FC236}">
+                    <a16:creationId xmlns:a16="http://schemas.microsoft.com/office/drawing/2014/main" id="{8FF74E31-97AE-78ED-5BC0-4E21A697A026}"/>
+                  </a:ext>
+                </a:extLst>
+              </p:cNvPr>
+              <p:cNvSpPr txBox="1"/>
+              <p:nvPr/>
+            </p:nvSpPr>
+            <p:spPr>
+              <a:xfrm>
+                <a:off x="9312078" y="4882524"/>
+                <a:ext cx="1267911" cy="276999"/>
+              </a:xfrm>
+              <a:prstGeom prst="rect">
+                <a:avLst/>
+              </a:prstGeom>
+              <a:noFill/>
+            </p:spPr>
+            <p:txBody>
+              <a:bodyPr wrap="none" lIns="0" tIns="0" rIns="0" bIns="0" rtlCol="0">
+                <a:spAutoFit/>
+              </a:bodyPr>
+              <a:lstStyle/>
+              <a:p>
+                <a14:m>
+                  <m:oMathPara xmlns:m="http://schemas.openxmlformats.org/officeDocument/2006/math">
+                    <m:oMathParaPr>
+                      <m:jc m:val="centerGroup"/>
+                    </m:oMathParaPr>
+                    <m:oMath xmlns:m="http://schemas.openxmlformats.org/officeDocument/2006/math">
+                      <m:sSub>
+                        <m:sSubPr>
+                          <m:ctrlPr>
+                            <a:rPr lang="en-US" i="1" smtClean="0">
+                              <a:latin typeface="Cambria Math" panose="02040503050406030204" pitchFamily="18" charset="0"/>
+                              <a:ea typeface="Cambria Math" panose="02040503050406030204" pitchFamily="18" charset="0"/>
+                            </a:rPr>
+                          </m:ctrlPr>
+                        </m:sSubPr>
+                        <m:e>
+                          <m:r>
+                            <a:rPr lang="en-US" i="1" smtClean="0">
+                              <a:latin typeface="Cambria Math" panose="02040503050406030204" pitchFamily="18" charset="0"/>
+                              <a:ea typeface="Cambria Math" panose="02040503050406030204" pitchFamily="18" charset="0"/>
+                            </a:rPr>
+                            <m:t>𝜂</m:t>
+                          </m:r>
+                        </m:e>
+                        <m:sub>
+                          <m:r>
+                            <m:rPr>
+                              <m:sty m:val="p"/>
+                            </m:rPr>
+                            <a:rPr lang="en-US" b="0" i="1" smtClean="0">
+                              <a:latin typeface="Cambria Math" panose="02040503050406030204" pitchFamily="18" charset="0"/>
+                              <a:ea typeface="Cambria Math" panose="02040503050406030204" pitchFamily="18" charset="0"/>
+                            </a:rPr>
+                            <m:t>net</m:t>
+                          </m:r>
+                        </m:sub>
+                      </m:sSub>
+                      <m:r>
+                        <a:rPr lang="en-US" i="1" smtClean="0">
+                          <a:latin typeface="Cambria Math" panose="02040503050406030204" pitchFamily="18" charset="0"/>
+                          <a:ea typeface="Cambria Math" panose="02040503050406030204" pitchFamily="18" charset="0"/>
+                        </a:rPr>
+                        <m:t>≈</m:t>
+                      </m:r>
+                      <m:r>
+                        <a:rPr lang="en-US" b="0" i="1" smtClean="0">
+                          <a:latin typeface="Cambria Math" panose="02040503050406030204" pitchFamily="18" charset="0"/>
+                          <a:ea typeface="Cambria Math" panose="02040503050406030204" pitchFamily="18" charset="0"/>
+                        </a:rPr>
+                        <m:t>6.8%</m:t>
+                      </m:r>
+                    </m:oMath>
+                  </m:oMathPara>
+                </a14:m>
+                <a:endParaRPr lang="en-US" dirty="0"/>
+              </a:p>
+            </p:txBody>
+          </p:sp>
+        </mc:Choice>
+        <mc:Fallback>
+          <p:sp>
+            <p:nvSpPr>
+              <p:cNvPr id="16" name="TextBox 15">
+                <a:extLst>
+                  <a:ext uri="{FF2B5EF4-FFF2-40B4-BE49-F238E27FC236}">
+                    <a16:creationId xmlns:a16="http://schemas.microsoft.com/office/drawing/2014/main" id="{8FF74E31-97AE-78ED-5BC0-4E21A697A026}"/>
+                  </a:ext>
+                </a:extLst>
+              </p:cNvPr>
+              <p:cNvSpPr txBox="1">
+                <a:spLocks noRot="1" noChangeAspect="1" noMove="1" noResize="1" noEditPoints="1" noAdjustHandles="1" noChangeArrowheads="1" noChangeShapeType="1" noTextEdit="1"/>
+              </p:cNvSpPr>
+              <p:nvPr/>
+            </p:nvSpPr>
+            <p:spPr>
+              <a:xfrm>
+                <a:off x="9312078" y="4882524"/>
+                <a:ext cx="1267911" cy="276999"/>
+              </a:xfrm>
+              <a:prstGeom prst="rect">
+                <a:avLst/>
+              </a:prstGeom>
+              <a:blipFill>
+                <a:blip r:embed="rId10"/>
+                <a:stretch>
+                  <a:fillRect l="-3960" r="-2970" b="-30435"/>
+                </a:stretch>
+              </a:blipFill>
+            </p:spPr>
+            <p:txBody>
+              <a:bodyPr/>
+              <a:lstStyle/>
+              <a:p>
+                <a:r>
+                  <a:rPr lang="en-US">
+                    <a:noFill/>
+                  </a:rPr>
+                  <a:t> </a:t>
+                </a:r>
+              </a:p>
+            </p:txBody>
+          </p:sp>
+        </mc:Fallback>
+      </mc:AlternateContent>
+    </p:spTree>
+    <p:extLst>
+      <p:ext uri="{BB962C8B-B14F-4D97-AF65-F5344CB8AC3E}">
+        <p14:creationId xmlns:p14="http://schemas.microsoft.com/office/powerpoint/2010/main" val="4194343597"/>
+      </p:ext>
+    </p:extLst>
+  </p:cSld>
+  <p:clrMapOvr>
+    <a:masterClrMapping/>
+  </p:clrMapOvr>
+</p:sld>
+</file>
+
+<file path=ppt/slides/slide13.xml><?xml version="1.0" encoding="utf-8"?>
+<p:sld xmlns:a="http://schemas.openxmlformats.org/drawingml/2006/main" xmlns:r="http://schemas.openxmlformats.org/officeDocument/2006/relationships" xmlns:p="http://schemas.openxmlformats.org/presentationml/2006/main">
+  <p:cSld>
+    <p:spTree>
+      <p:nvGrpSpPr>
+        <p:cNvPr id="1" name="">
+          <a:extLst>
+            <a:ext uri="{FF2B5EF4-FFF2-40B4-BE49-F238E27FC236}">
+              <a16:creationId xmlns:a16="http://schemas.microsoft.com/office/drawing/2014/main" id="{CEA8BBDD-1144-7594-7DB0-86DDC755FADB}"/>
+            </a:ext>
+          </a:extLst>
+        </p:cNvPr>
+        <p:cNvGrpSpPr/>
+        <p:nvPr/>
+      </p:nvGrpSpPr>
+      <p:grpSpPr>
+        <a:xfrm>
+          <a:off x="0" y="0"/>
+          <a:ext cx="0" cy="0"/>
+          <a:chOff x="0" y="0"/>
+          <a:chExt cx="0" cy="0"/>
+        </a:xfrm>
+      </p:grpSpPr>
+      <p:sp>
+        <p:nvSpPr>
+          <p:cNvPr id="4" name="Title 3">
+            <a:extLst>
+              <a:ext uri="{FF2B5EF4-FFF2-40B4-BE49-F238E27FC236}">
+                <a16:creationId xmlns:a16="http://schemas.microsoft.com/office/drawing/2014/main" id="{3C98AA7A-5513-D4D9-89BD-C72CD7B6E18B}"/>
+              </a:ext>
+            </a:extLst>
+          </p:cNvPr>
+          <p:cNvSpPr>
+            <a:spLocks noGrp="1"/>
+          </p:cNvSpPr>
+          <p:nvPr>
+            <p:ph type="title"/>
+          </p:nvPr>
+        </p:nvSpPr>
+        <p:spPr/>
+        <p:txBody>
+          <a:bodyPr>
+            <a:normAutofit fontScale="90000"/>
+          </a:bodyPr>
+          <a:lstStyle/>
+          <a:p>
+            <a:r>
+              <a:rPr lang="en-US" dirty="0">
+                <a:solidFill>
+                  <a:schemeClr val="bg1"/>
+                </a:solidFill>
+              </a:rPr>
+              <a:t>Off-Centre Impact – Thread Failure </a:t>
+            </a:r>
+            <a:endParaRPr lang="ro-RO" dirty="0">
+              <a:solidFill>
+                <a:schemeClr val="bg1"/>
+              </a:solidFill>
+            </a:endParaRPr>
+          </a:p>
+        </p:txBody>
+      </p:sp>
+      <p:pic>
+        <p:nvPicPr>
+          <p:cNvPr id="5" name="Picture 4">
+            <a:extLst>
+              <a:ext uri="{FF2B5EF4-FFF2-40B4-BE49-F238E27FC236}">
+                <a16:creationId xmlns:a16="http://schemas.microsoft.com/office/drawing/2014/main" id="{97CA049E-F40C-C204-D85C-1D2212E5E0AB}"/>
+              </a:ext>
+            </a:extLst>
+          </p:cNvPr>
+          <p:cNvPicPr>
+            <a:picLocks noChangeAspect="1"/>
+          </p:cNvPicPr>
+          <p:nvPr/>
+        </p:nvPicPr>
+        <p:blipFill>
+          <a:blip r:embed="rId2">
+            <a:clrChange>
+              <a:clrFrom>
+                <a:srgbClr val="000000"/>
+              </a:clrFrom>
+              <a:clrTo>
+                <a:srgbClr val="000000">
+                  <a:alpha val="0"/>
+                </a:srgbClr>
+              </a:clrTo>
+            </a:clrChange>
+            <a:extLst>
+              <a:ext uri="{28A0092B-C50C-407E-A947-70E740481C1C}">
+                <a14:useLocalDpi xmlns:a14="http://schemas.microsoft.com/office/drawing/2010/main" val="0"/>
+              </a:ext>
+            </a:extLst>
+          </a:blip>
+          <a:stretch>
+            <a:fillRect/>
+          </a:stretch>
+        </p:blipFill>
+        <p:spPr>
+          <a:xfrm>
+            <a:off x="10432471" y="6323329"/>
+            <a:ext cx="1492133" cy="496892"/>
+          </a:xfrm>
+          <a:prstGeom prst="rect">
+            <a:avLst/>
+          </a:prstGeom>
+        </p:spPr>
+      </p:pic>
+    </p:spTree>
+    <p:extLst>
+      <p:ext uri="{BB962C8B-B14F-4D97-AF65-F5344CB8AC3E}">
+        <p14:creationId xmlns:p14="http://schemas.microsoft.com/office/powerpoint/2010/main" val="63522783"/>
       </p:ext>
     </p:extLst>
   </p:cSld>

</xml_diff>